<commit_message>
data: change in the presentation and also the project document
</commit_message>
<xml_diff>
--- a/documents/luxeintelligence.pptx
+++ b/documents/luxeintelligence.pptx
@@ -12,11 +12,12 @@
     <p:sldId id="263" r:id="rId6"/>
     <p:sldId id="260" r:id="rId7"/>
     <p:sldId id="261" r:id="rId8"/>
-    <p:sldId id="262" r:id="rId9"/>
-    <p:sldId id="264" r:id="rId10"/>
-    <p:sldId id="265" r:id="rId11"/>
-    <p:sldId id="266" r:id="rId12"/>
-    <p:sldId id="267" r:id="rId13"/>
+    <p:sldId id="268" r:id="rId9"/>
+    <p:sldId id="262" r:id="rId10"/>
+    <p:sldId id="264" r:id="rId11"/>
+    <p:sldId id="265" r:id="rId12"/>
+    <p:sldId id="266" r:id="rId13"/>
+    <p:sldId id="267" r:id="rId14"/>
   </p:sldIdLst>
   <p:sldSz cx="12192000" cy="6858000"/>
   <p:notesSz cx="6858000" cy="9144000"/>
@@ -311,7 +312,7 @@
           <a:p>
             <a:fld id="{8733D1AA-C967-485F-9C0F-3A10FB3D7970}" type="datetimeFigureOut">
               <a:rPr lang="it-IT" smtClean="0"/>
-              <a:t>03/03/2026</a:t>
+              <a:t>10/03/2026</a:t>
             </a:fld>
             <a:endParaRPr lang="it-IT"/>
           </a:p>
@@ -649,7 +650,7 @@
           <a:p>
             <a:fld id="{8733D1AA-C967-485F-9C0F-3A10FB3D7970}" type="datetimeFigureOut">
               <a:rPr lang="it-IT" smtClean="0"/>
-              <a:t>03/03/2026</a:t>
+              <a:t>10/03/2026</a:t>
             </a:fld>
             <a:endParaRPr lang="it-IT"/>
           </a:p>
@@ -1050,7 +1051,7 @@
           <a:p>
             <a:fld id="{8733D1AA-C967-485F-9C0F-3A10FB3D7970}" type="datetimeFigureOut">
               <a:rPr lang="it-IT" smtClean="0"/>
-              <a:t>03/03/2026</a:t>
+              <a:t>10/03/2026</a:t>
             </a:fld>
             <a:endParaRPr lang="it-IT"/>
           </a:p>
@@ -1386,7 +1387,7 @@
           <a:p>
             <a:fld id="{8733D1AA-C967-485F-9C0F-3A10FB3D7970}" type="datetimeFigureOut">
               <a:rPr lang="it-IT" smtClean="0"/>
-              <a:t>03/03/2026</a:t>
+              <a:t>10/03/2026</a:t>
             </a:fld>
             <a:endParaRPr lang="it-IT"/>
           </a:p>
@@ -1706,7 +1707,7 @@
           <a:p>
             <a:fld id="{8733D1AA-C967-485F-9C0F-3A10FB3D7970}" type="datetimeFigureOut">
               <a:rPr lang="it-IT" smtClean="0"/>
-              <a:t>03/03/2026</a:t>
+              <a:t>10/03/2026</a:t>
             </a:fld>
             <a:endParaRPr lang="it-IT"/>
           </a:p>
@@ -2102,7 +2103,7 @@
           <a:p>
             <a:fld id="{8733D1AA-C967-485F-9C0F-3A10FB3D7970}" type="datetimeFigureOut">
               <a:rPr lang="it-IT" smtClean="0"/>
-              <a:t>03/03/2026</a:t>
+              <a:t>10/03/2026</a:t>
             </a:fld>
             <a:endParaRPr lang="it-IT"/>
           </a:p>
@@ -2359,7 +2360,7 @@
           <a:p>
             <a:fld id="{8733D1AA-C967-485F-9C0F-3A10FB3D7970}" type="datetimeFigureOut">
               <a:rPr lang="it-IT" smtClean="0"/>
-              <a:t>03/03/2026</a:t>
+              <a:t>10/03/2026</a:t>
             </a:fld>
             <a:endParaRPr lang="it-IT"/>
           </a:p>
@@ -2621,7 +2622,7 @@
           <a:p>
             <a:fld id="{8733D1AA-C967-485F-9C0F-3A10FB3D7970}" type="datetimeFigureOut">
               <a:rPr lang="it-IT" smtClean="0"/>
-              <a:t>03/03/2026</a:t>
+              <a:t>10/03/2026</a:t>
             </a:fld>
             <a:endParaRPr lang="it-IT"/>
           </a:p>
@@ -2883,7 +2884,7 @@
           <a:p>
             <a:fld id="{8733D1AA-C967-485F-9C0F-3A10FB3D7970}" type="datetimeFigureOut">
               <a:rPr lang="it-IT" smtClean="0"/>
-              <a:t>03/03/2026</a:t>
+              <a:t>10/03/2026</a:t>
             </a:fld>
             <a:endParaRPr lang="it-IT"/>
           </a:p>
@@ -3212,7 +3213,7 @@
           <a:p>
             <a:fld id="{8733D1AA-C967-485F-9C0F-3A10FB3D7970}" type="datetimeFigureOut">
               <a:rPr lang="it-IT" smtClean="0"/>
-              <a:t>03/03/2026</a:t>
+              <a:t>10/03/2026</a:t>
             </a:fld>
             <a:endParaRPr lang="it-IT"/>
           </a:p>
@@ -3535,7 +3536,7 @@
           <a:p>
             <a:fld id="{8733D1AA-C967-485F-9C0F-3A10FB3D7970}" type="datetimeFigureOut">
               <a:rPr lang="it-IT" smtClean="0"/>
-              <a:t>03/03/2026</a:t>
+              <a:t>10/03/2026</a:t>
             </a:fld>
             <a:endParaRPr lang="it-IT"/>
           </a:p>
@@ -3992,7 +3993,7 @@
           <a:p>
             <a:fld id="{8733D1AA-C967-485F-9C0F-3A10FB3D7970}" type="datetimeFigureOut">
               <a:rPr lang="it-IT" smtClean="0"/>
-              <a:t>03/03/2026</a:t>
+              <a:t>10/03/2026</a:t>
             </a:fld>
             <a:endParaRPr lang="it-IT"/>
           </a:p>
@@ -4197,7 +4198,7 @@
           <a:p>
             <a:fld id="{8733D1AA-C967-485F-9C0F-3A10FB3D7970}" type="datetimeFigureOut">
               <a:rPr lang="it-IT" smtClean="0"/>
-              <a:t>03/03/2026</a:t>
+              <a:t>10/03/2026</a:t>
             </a:fld>
             <a:endParaRPr lang="it-IT"/>
           </a:p>
@@ -4374,7 +4375,7 @@
           <a:p>
             <a:fld id="{8733D1AA-C967-485F-9C0F-3A10FB3D7970}" type="datetimeFigureOut">
               <a:rPr lang="it-IT" smtClean="0"/>
-              <a:t>03/03/2026</a:t>
+              <a:t>10/03/2026</a:t>
             </a:fld>
             <a:endParaRPr lang="it-IT"/>
           </a:p>
@@ -4707,7 +4708,7 @@
           <a:p>
             <a:fld id="{8733D1AA-C967-485F-9C0F-3A10FB3D7970}" type="datetimeFigureOut">
               <a:rPr lang="it-IT" smtClean="0"/>
-              <a:t>03/03/2026</a:t>
+              <a:t>10/03/2026</a:t>
             </a:fld>
             <a:endParaRPr lang="it-IT"/>
           </a:p>
@@ -5052,7 +5053,7 @@
           <a:p>
             <a:fld id="{8733D1AA-C967-485F-9C0F-3A10FB3D7970}" type="datetimeFigureOut">
               <a:rPr lang="it-IT" smtClean="0"/>
-              <a:t>03/03/2026</a:t>
+              <a:t>10/03/2026</a:t>
             </a:fld>
             <a:endParaRPr lang="it-IT"/>
           </a:p>
@@ -7169,7 +7170,7 @@
           <a:p>
             <a:fld id="{8733D1AA-C967-485F-9C0F-3A10FB3D7970}" type="datetimeFigureOut">
               <a:rPr lang="it-IT" smtClean="0"/>
-              <a:t>03/03/2026</a:t>
+              <a:t>10/03/2026</a:t>
             </a:fld>
             <a:endParaRPr lang="it-IT"/>
           </a:p>
@@ -7837,6 +7838,331 @@
           <a:chExt cx="0" cy="0"/>
         </a:xfrm>
       </p:grpSpPr>
+      <p:pic>
+        <p:nvPicPr>
+          <p:cNvPr id="4" name="Immagine 3">
+            <a:extLst>
+              <a:ext uri="{FF2B5EF4-FFF2-40B4-BE49-F238E27FC236}">
+                <a16:creationId xmlns:a16="http://schemas.microsoft.com/office/drawing/2014/main" id="{797287A1-0FF5-40FC-AD2A-1ED2CF0D132C}"/>
+              </a:ext>
+            </a:extLst>
+          </p:cNvPr>
+          <p:cNvPicPr/>
+          <p:nvPr/>
+        </p:nvPicPr>
+        <p:blipFill>
+          <a:blip r:embed="rId2">
+            <a:extLst>
+              <a:ext uri="{28A0092B-C50C-407E-A947-70E740481C1C}">
+                <a14:useLocalDpi xmlns:a14="http://schemas.microsoft.com/office/drawing/2010/main" val="0"/>
+              </a:ext>
+            </a:extLst>
+          </a:blip>
+          <a:stretch>
+            <a:fillRect/>
+          </a:stretch>
+        </p:blipFill>
+        <p:spPr>
+          <a:xfrm>
+            <a:off x="203516" y="0"/>
+            <a:ext cx="5892483" cy="3629320"/>
+          </a:xfrm>
+          <a:prstGeom prst="rect">
+            <a:avLst/>
+          </a:prstGeom>
+        </p:spPr>
+      </p:pic>
+      <p:sp>
+        <p:nvSpPr>
+          <p:cNvPr id="5" name="Rettangolo 4">
+            <a:extLst>
+              <a:ext uri="{FF2B5EF4-FFF2-40B4-BE49-F238E27FC236}">
+                <a16:creationId xmlns:a16="http://schemas.microsoft.com/office/drawing/2014/main" id="{17B9DAAB-F413-4CB1-BC5D-1AB58488F3E2}"/>
+              </a:ext>
+            </a:extLst>
+          </p:cNvPr>
+          <p:cNvSpPr/>
+          <p:nvPr/>
+        </p:nvSpPr>
+        <p:spPr>
+          <a:xfrm>
+            <a:off x="6488576" y="340878"/>
+            <a:ext cx="2929007" cy="369332"/>
+          </a:xfrm>
+          <a:prstGeom prst="rect">
+            <a:avLst/>
+          </a:prstGeom>
+        </p:spPr>
+        <p:txBody>
+          <a:bodyPr wrap="none">
+            <a:spAutoFit/>
+          </a:bodyPr>
+          <a:lstStyle/>
+          <a:p>
+            <a:r>
+              <a:rPr lang="en-IN" b="1" dirty="0">
+                <a:latin typeface="Times New Roman" panose="02020603050405020304" pitchFamily="18" charset="0"/>
+                <a:ea typeface="Times New Roman" panose="02020603050405020304" pitchFamily="18" charset="0"/>
+              </a:rPr>
+              <a:t>Goldilocks Zone ($100–250)</a:t>
+            </a:r>
+            <a:endParaRPr lang="it-IT" dirty="0"/>
+          </a:p>
+        </p:txBody>
+      </p:sp>
+      <p:sp>
+        <p:nvSpPr>
+          <p:cNvPr id="6" name="Rettangolo 5">
+            <a:extLst>
+              <a:ext uri="{FF2B5EF4-FFF2-40B4-BE49-F238E27FC236}">
+                <a16:creationId xmlns:a16="http://schemas.microsoft.com/office/drawing/2014/main" id="{CA1AA25B-92E3-4A4C-ACA5-91AD32654BAA}"/>
+              </a:ext>
+            </a:extLst>
+          </p:cNvPr>
+          <p:cNvSpPr/>
+          <p:nvPr/>
+        </p:nvSpPr>
+        <p:spPr>
+          <a:xfrm>
+            <a:off x="6488576" y="906486"/>
+            <a:ext cx="3070071" cy="369332"/>
+          </a:xfrm>
+          <a:prstGeom prst="rect">
+            <a:avLst/>
+          </a:prstGeom>
+        </p:spPr>
+        <p:txBody>
+          <a:bodyPr wrap="none">
+            <a:spAutoFit/>
+          </a:bodyPr>
+          <a:lstStyle/>
+          <a:p>
+            <a:r>
+              <a:rPr lang="en-IN" b="1" dirty="0">
+                <a:latin typeface="Times New Roman" panose="02020603050405020304" pitchFamily="18" charset="0"/>
+                <a:ea typeface="Times New Roman" panose="02020603050405020304" pitchFamily="18" charset="0"/>
+              </a:rPr>
+              <a:t>Positive Momentum ($0–100)</a:t>
+            </a:r>
+            <a:endParaRPr lang="it-IT" dirty="0"/>
+          </a:p>
+        </p:txBody>
+      </p:sp>
+      <p:sp>
+        <p:nvSpPr>
+          <p:cNvPr id="7" name="Rettangolo 6">
+            <a:extLst>
+              <a:ext uri="{FF2B5EF4-FFF2-40B4-BE49-F238E27FC236}">
+                <a16:creationId xmlns:a16="http://schemas.microsoft.com/office/drawing/2014/main" id="{E1A4F43A-9EA4-46BD-AF28-B1DCC3DCC9B2}"/>
+              </a:ext>
+            </a:extLst>
+          </p:cNvPr>
+          <p:cNvSpPr/>
+          <p:nvPr/>
+        </p:nvSpPr>
+        <p:spPr>
+          <a:xfrm>
+            <a:off x="6488576" y="1472094"/>
+            <a:ext cx="3533018" cy="369332"/>
+          </a:xfrm>
+          <a:prstGeom prst="rect">
+            <a:avLst/>
+          </a:prstGeom>
+        </p:spPr>
+        <p:txBody>
+          <a:bodyPr wrap="none">
+            <a:spAutoFit/>
+          </a:bodyPr>
+          <a:lstStyle/>
+          <a:p>
+            <a:r>
+              <a:rPr lang="en-IN" b="1" dirty="0">
+                <a:latin typeface="Times New Roman" panose="02020603050405020304" pitchFamily="18" charset="0"/>
+                <a:ea typeface="Times New Roman" panose="02020603050405020304" pitchFamily="18" charset="0"/>
+              </a:rPr>
+              <a:t>The Resistance Threshold ($250+)</a:t>
+            </a:r>
+            <a:endParaRPr lang="it-IT" dirty="0"/>
+          </a:p>
+        </p:txBody>
+      </p:sp>
+      <p:sp>
+        <p:nvSpPr>
+          <p:cNvPr id="8" name="Rettangolo 7">
+            <a:extLst>
+              <a:ext uri="{FF2B5EF4-FFF2-40B4-BE49-F238E27FC236}">
+                <a16:creationId xmlns:a16="http://schemas.microsoft.com/office/drawing/2014/main" id="{6721472B-5121-4275-BD4C-B776324F5071}"/>
+              </a:ext>
+            </a:extLst>
+          </p:cNvPr>
+          <p:cNvSpPr/>
+          <p:nvPr/>
+        </p:nvSpPr>
+        <p:spPr>
+          <a:xfrm>
+            <a:off x="6489537" y="2037702"/>
+            <a:ext cx="2928046" cy="369332"/>
+          </a:xfrm>
+          <a:prstGeom prst="rect">
+            <a:avLst/>
+          </a:prstGeom>
+        </p:spPr>
+        <p:txBody>
+          <a:bodyPr wrap="none">
+            <a:spAutoFit/>
+          </a:bodyPr>
+          <a:lstStyle/>
+          <a:p>
+            <a:r>
+              <a:rPr lang="en-IN" b="1" dirty="0">
+                <a:latin typeface="Times New Roman" panose="02020603050405020304" pitchFamily="18" charset="0"/>
+                <a:ea typeface="Times New Roman" panose="02020603050405020304" pitchFamily="18" charset="0"/>
+              </a:rPr>
+              <a:t>High-Ticket Friction ($1k+)</a:t>
+            </a:r>
+            <a:endParaRPr lang="it-IT" dirty="0"/>
+          </a:p>
+        </p:txBody>
+      </p:sp>
+      <p:pic>
+        <p:nvPicPr>
+          <p:cNvPr id="9" name="Immagine 8">
+            <a:extLst>
+              <a:ext uri="{FF2B5EF4-FFF2-40B4-BE49-F238E27FC236}">
+                <a16:creationId xmlns:a16="http://schemas.microsoft.com/office/drawing/2014/main" id="{751423F0-F71C-405E-90E7-D8D9FF22BDA6}"/>
+              </a:ext>
+            </a:extLst>
+          </p:cNvPr>
+          <p:cNvPicPr/>
+          <p:nvPr/>
+        </p:nvPicPr>
+        <p:blipFill>
+          <a:blip r:embed="rId3">
+            <a:extLst>
+              <a:ext uri="{28A0092B-C50C-407E-A947-70E740481C1C}">
+                <a14:useLocalDpi xmlns:a14="http://schemas.microsoft.com/office/drawing/2010/main" val="0"/>
+              </a:ext>
+            </a:extLst>
+          </a:blip>
+          <a:stretch>
+            <a:fillRect/>
+          </a:stretch>
+        </p:blipFill>
+        <p:spPr>
+          <a:xfrm>
+            <a:off x="203516" y="3629320"/>
+            <a:ext cx="5892482" cy="3217545"/>
+          </a:xfrm>
+          <a:prstGeom prst="rect">
+            <a:avLst/>
+          </a:prstGeom>
+        </p:spPr>
+      </p:pic>
+      <p:sp>
+        <p:nvSpPr>
+          <p:cNvPr id="10" name="Rettangolo 9">
+            <a:extLst>
+              <a:ext uri="{FF2B5EF4-FFF2-40B4-BE49-F238E27FC236}">
+                <a16:creationId xmlns:a16="http://schemas.microsoft.com/office/drawing/2014/main" id="{9735EFBE-E4DE-4D51-A976-2C3B9C85AB06}"/>
+              </a:ext>
+            </a:extLst>
+          </p:cNvPr>
+          <p:cNvSpPr/>
+          <p:nvPr/>
+        </p:nvSpPr>
+        <p:spPr>
+          <a:xfrm>
+            <a:off x="6281394" y="4267515"/>
+            <a:ext cx="5492685" cy="1754326"/>
+          </a:xfrm>
+          <a:prstGeom prst="rect">
+            <a:avLst/>
+          </a:prstGeom>
+        </p:spPr>
+        <p:txBody>
+          <a:bodyPr wrap="square">
+            <a:spAutoFit/>
+          </a:bodyPr>
+          <a:lstStyle/>
+          <a:p>
+            <a:r>
+              <a:rPr lang="en-US" dirty="0"/>
+              <a:t>The revenue analysis reveals a clear market preference for classic patterns, with </a:t>
+            </a:r>
+            <a:r>
+              <a:rPr lang="en-US" b="1" dirty="0"/>
+              <a:t>Botanical</a:t>
+            </a:r>
+            <a:r>
+              <a:rPr lang="en-US" dirty="0"/>
+              <a:t>, </a:t>
+            </a:r>
+            <a:r>
+              <a:rPr lang="en-US" b="1" dirty="0"/>
+              <a:t>Solid</a:t>
+            </a:r>
+            <a:r>
+              <a:rPr lang="en-US" dirty="0"/>
+              <a:t>, and </a:t>
+            </a:r>
+            <a:r>
+              <a:rPr lang="en-US" b="1" dirty="0"/>
+              <a:t>Floral</a:t>
+            </a:r>
+            <a:r>
+              <a:rPr lang="en-US" dirty="0"/>
+              <a:t> motifs emerging as the primary revenue drivers, each generating nearly double the individual revenue of mid-tier categories like </a:t>
+            </a:r>
+            <a:r>
+              <a:rPr lang="en-US" b="1" dirty="0"/>
+              <a:t>Geometric</a:t>
+            </a:r>
+            <a:r>
+              <a:rPr lang="en-US" dirty="0"/>
+              <a:t> or </a:t>
+            </a:r>
+            <a:r>
+              <a:rPr lang="en-US" b="1" dirty="0"/>
+              <a:t>Texture</a:t>
+            </a:r>
+            <a:r>
+              <a:rPr lang="en-US" dirty="0"/>
+              <a:t>.</a:t>
+            </a:r>
+            <a:endParaRPr lang="it-IT" dirty="0"/>
+          </a:p>
+        </p:txBody>
+      </p:sp>
+    </p:spTree>
+    <p:extLst>
+      <p:ext uri="{BB962C8B-B14F-4D97-AF65-F5344CB8AC3E}">
+        <p14:creationId xmlns:p14="http://schemas.microsoft.com/office/powerpoint/2010/main" val="3324384585"/>
+      </p:ext>
+    </p:extLst>
+  </p:cSld>
+  <p:clrMapOvr>
+    <a:masterClrMapping/>
+  </p:clrMapOvr>
+</p:sld>
+</file>
+
+<file path=ppt/slides/slide11.xml><?xml version="1.0" encoding="utf-8"?>
+<p:sld xmlns:a="http://schemas.openxmlformats.org/drawingml/2006/main" xmlns:r="http://schemas.openxmlformats.org/officeDocument/2006/relationships" xmlns:p="http://schemas.openxmlformats.org/presentationml/2006/main">
+  <p:cSld>
+    <p:spTree>
+      <p:nvGrpSpPr>
+        <p:cNvPr id="1" name=""/>
+        <p:cNvGrpSpPr/>
+        <p:nvPr/>
+      </p:nvGrpSpPr>
+      <p:grpSpPr>
+        <a:xfrm>
+          <a:off x="0" y="0"/>
+          <a:ext cx="0" cy="0"/>
+          <a:chOff x="0" y="0"/>
+          <a:chExt cx="0" cy="0"/>
+        </a:xfrm>
+      </p:grpSpPr>
       <p:sp>
         <p:nvSpPr>
           <p:cNvPr id="2" name="Titolo 1">
@@ -7965,7 +8291,7 @@
 </p:sld>
 </file>
 
-<file path=ppt/slides/slide11.xml><?xml version="1.0" encoding="utf-8"?>
+<file path=ppt/slides/slide12.xml><?xml version="1.0" encoding="utf-8"?>
 <p:sld xmlns:a="http://schemas.openxmlformats.org/drawingml/2006/main" xmlns:r="http://schemas.openxmlformats.org/officeDocument/2006/relationships" xmlns:p="http://schemas.openxmlformats.org/presentationml/2006/main" showMasterSp="0">
   <p:cSld>
     <p:bg>
@@ -8279,7 +8605,7 @@
 </p:sld>
 </file>
 
-<file path=ppt/slides/slide12.xml><?xml version="1.0" encoding="utf-8"?>
+<file path=ppt/slides/slide13.xml><?xml version="1.0" encoding="utf-8"?>
 <p:sld xmlns:a="http://schemas.openxmlformats.org/drawingml/2006/main" xmlns:r="http://schemas.openxmlformats.org/officeDocument/2006/relationships" xmlns:p="http://schemas.openxmlformats.org/presentationml/2006/main" showMasterSp="0">
   <p:cSld>
     <p:bg>
@@ -11304,6 +11630,682 @@
           <p:cNvPr id="2" name="Titolo 1">
             <a:extLst>
               <a:ext uri="{FF2B5EF4-FFF2-40B4-BE49-F238E27FC236}">
+                <a16:creationId xmlns:a16="http://schemas.microsoft.com/office/drawing/2014/main" id="{A0CA2CD5-5A4D-413B-9BF4-7ECF200146E0}"/>
+              </a:ext>
+            </a:extLst>
+          </p:cNvPr>
+          <p:cNvSpPr>
+            <a:spLocks noGrp="1"/>
+          </p:cNvSpPr>
+          <p:nvPr>
+            <p:ph type="title"/>
+          </p:nvPr>
+        </p:nvSpPr>
+        <p:spPr>
+          <a:xfrm>
+            <a:off x="1677972" y="96209"/>
+            <a:ext cx="10275215" cy="771057"/>
+          </a:xfrm>
+        </p:spPr>
+        <p:txBody>
+          <a:bodyPr>
+            <a:normAutofit/>
+          </a:bodyPr>
+          <a:lstStyle/>
+          <a:p>
+            <a:r>
+              <a:rPr lang="en-IN" sz="3200" b="1" dirty="0"/>
+              <a:t>KNN IMPLEMENTATION (Bug fix implemented)</a:t>
+            </a:r>
+            <a:endParaRPr lang="it-IT" sz="3200" dirty="0"/>
+          </a:p>
+        </p:txBody>
+      </p:sp>
+      <p:pic>
+        <p:nvPicPr>
+          <p:cNvPr id="6" name="Segnaposto contenuto 5">
+            <a:extLst>
+              <a:ext uri="{FF2B5EF4-FFF2-40B4-BE49-F238E27FC236}">
+                <a16:creationId xmlns:a16="http://schemas.microsoft.com/office/drawing/2014/main" id="{B74CE5B5-775F-48C9-A063-E8D874CCC8C6}"/>
+              </a:ext>
+            </a:extLst>
+          </p:cNvPr>
+          <p:cNvPicPr>
+            <a:picLocks noGrp="1" noChangeAspect="1"/>
+          </p:cNvPicPr>
+          <p:nvPr>
+            <p:ph idx="1"/>
+          </p:nvPr>
+        </p:nvPicPr>
+        <p:blipFill>
+          <a:blip r:embed="rId2">
+            <a:extLst>
+              <a:ext uri="{28A0092B-C50C-407E-A947-70E740481C1C}">
+                <a14:useLocalDpi xmlns:a14="http://schemas.microsoft.com/office/drawing/2010/main" val="0"/>
+              </a:ext>
+            </a:extLst>
+          </a:blip>
+          <a:stretch>
+            <a:fillRect/>
+          </a:stretch>
+        </p:blipFill>
+        <p:spPr>
+          <a:xfrm>
+            <a:off x="304943" y="1813252"/>
+            <a:ext cx="6510636" cy="3778250"/>
+          </a:xfrm>
+        </p:spPr>
+      </p:pic>
+      <p:sp>
+        <p:nvSpPr>
+          <p:cNvPr id="4" name="Rettangolo 3">
+            <a:extLst>
+              <a:ext uri="{FF2B5EF4-FFF2-40B4-BE49-F238E27FC236}">
+                <a16:creationId xmlns:a16="http://schemas.microsoft.com/office/drawing/2014/main" id="{D0E31086-F3FA-4405-9F50-00D7141B7F37}"/>
+              </a:ext>
+            </a:extLst>
+          </p:cNvPr>
+          <p:cNvSpPr/>
+          <p:nvPr/>
+        </p:nvSpPr>
+        <p:spPr>
+          <a:xfrm>
+            <a:off x="1757982" y="737745"/>
+            <a:ext cx="8347552" cy="634854"/>
+          </a:xfrm>
+          <a:prstGeom prst="rect">
+            <a:avLst/>
+          </a:prstGeom>
+        </p:spPr>
+        <p:txBody>
+          <a:bodyPr wrap="square">
+            <a:spAutoFit/>
+          </a:bodyPr>
+          <a:lstStyle/>
+          <a:p>
+            <a:pPr>
+              <a:lnSpc>
+                <a:spcPct val="115000"/>
+              </a:lnSpc>
+              <a:spcBef>
+                <a:spcPts val="500"/>
+              </a:spcBef>
+              <a:spcAft>
+                <a:spcPts val="0"/>
+              </a:spcAft>
+            </a:pPr>
+            <a:r>
+              <a:rPr lang="en-IN" sz="1400" dirty="0" err="1">
+                <a:solidFill>
+                  <a:srgbClr val="00B050"/>
+                </a:solidFill>
+                <a:latin typeface="Consolas" panose="020B0609020204030204" pitchFamily="49" charset="0"/>
+                <a:ea typeface="Times New Roman" panose="02020603050405020304" pitchFamily="18" charset="0"/>
+                <a:cs typeface="Times New Roman" panose="02020603050405020304" pitchFamily="18" charset="0"/>
+              </a:rPr>
+              <a:t>kmeans</a:t>
+            </a:r>
+            <a:r>
+              <a:rPr lang="en-IN" sz="1400" dirty="0">
+                <a:solidFill>
+                  <a:srgbClr val="00B050"/>
+                </a:solidFill>
+                <a:latin typeface="Consolas" panose="020B0609020204030204" pitchFamily="49" charset="0"/>
+                <a:ea typeface="Times New Roman" panose="02020603050405020304" pitchFamily="18" charset="0"/>
+                <a:cs typeface="Times New Roman" panose="02020603050405020304" pitchFamily="18" charset="0"/>
+              </a:rPr>
+              <a:t> = </a:t>
+            </a:r>
+            <a:r>
+              <a:rPr lang="en-IN" sz="1400" dirty="0" err="1">
+                <a:solidFill>
+                  <a:srgbClr val="00B050"/>
+                </a:solidFill>
+                <a:latin typeface="Consolas" panose="020B0609020204030204" pitchFamily="49" charset="0"/>
+                <a:ea typeface="Times New Roman" panose="02020603050405020304" pitchFamily="18" charset="0"/>
+                <a:cs typeface="Times New Roman" panose="02020603050405020304" pitchFamily="18" charset="0"/>
+              </a:rPr>
+              <a:t>KMeans</a:t>
+            </a:r>
+            <a:r>
+              <a:rPr lang="en-IN" sz="1400" dirty="0">
+                <a:solidFill>
+                  <a:srgbClr val="00B050"/>
+                </a:solidFill>
+                <a:latin typeface="Consolas" panose="020B0609020204030204" pitchFamily="49" charset="0"/>
+                <a:ea typeface="Times New Roman" panose="02020603050405020304" pitchFamily="18" charset="0"/>
+                <a:cs typeface="Times New Roman" panose="02020603050405020304" pitchFamily="18" charset="0"/>
+              </a:rPr>
+              <a:t>(</a:t>
+            </a:r>
+            <a:r>
+              <a:rPr lang="en-IN" sz="1400" dirty="0" err="1">
+                <a:solidFill>
+                  <a:srgbClr val="00B050"/>
+                </a:solidFill>
+                <a:latin typeface="Consolas" panose="020B0609020204030204" pitchFamily="49" charset="0"/>
+                <a:ea typeface="Times New Roman" panose="02020603050405020304" pitchFamily="18" charset="0"/>
+                <a:cs typeface="Times New Roman" panose="02020603050405020304" pitchFamily="18" charset="0"/>
+              </a:rPr>
+              <a:t>n_clusters</a:t>
+            </a:r>
+            <a:r>
+              <a:rPr lang="en-IN" sz="1400" dirty="0">
+                <a:solidFill>
+                  <a:srgbClr val="00B050"/>
+                </a:solidFill>
+                <a:latin typeface="Consolas" panose="020B0609020204030204" pitchFamily="49" charset="0"/>
+                <a:ea typeface="Times New Roman" panose="02020603050405020304" pitchFamily="18" charset="0"/>
+                <a:cs typeface="Times New Roman" panose="02020603050405020304" pitchFamily="18" charset="0"/>
+              </a:rPr>
+              <a:t>=4, </a:t>
+            </a:r>
+            <a:r>
+              <a:rPr lang="en-IN" sz="1400" dirty="0" err="1">
+                <a:solidFill>
+                  <a:srgbClr val="00B050"/>
+                </a:solidFill>
+                <a:latin typeface="Consolas" panose="020B0609020204030204" pitchFamily="49" charset="0"/>
+                <a:ea typeface="Times New Roman" panose="02020603050405020304" pitchFamily="18" charset="0"/>
+                <a:cs typeface="Times New Roman" panose="02020603050405020304" pitchFamily="18" charset="0"/>
+              </a:rPr>
+              <a:t>random_state</a:t>
+            </a:r>
+            <a:r>
+              <a:rPr lang="en-IN" sz="1400" dirty="0">
+                <a:solidFill>
+                  <a:srgbClr val="00B050"/>
+                </a:solidFill>
+                <a:latin typeface="Consolas" panose="020B0609020204030204" pitchFamily="49" charset="0"/>
+                <a:ea typeface="Times New Roman" panose="02020603050405020304" pitchFamily="18" charset="0"/>
+                <a:cs typeface="Times New Roman" panose="02020603050405020304" pitchFamily="18" charset="0"/>
+              </a:rPr>
+              <a:t>=42, </a:t>
+            </a:r>
+            <a:r>
+              <a:rPr lang="en-IN" sz="1400" dirty="0" err="1">
+                <a:solidFill>
+                  <a:srgbClr val="00B050"/>
+                </a:solidFill>
+                <a:latin typeface="Consolas" panose="020B0609020204030204" pitchFamily="49" charset="0"/>
+                <a:ea typeface="Times New Roman" panose="02020603050405020304" pitchFamily="18" charset="0"/>
+                <a:cs typeface="Times New Roman" panose="02020603050405020304" pitchFamily="18" charset="0"/>
+              </a:rPr>
+              <a:t>n_init</a:t>
+            </a:r>
+            <a:r>
+              <a:rPr lang="en-IN" sz="1400" dirty="0">
+                <a:solidFill>
+                  <a:srgbClr val="00B050"/>
+                </a:solidFill>
+                <a:latin typeface="Consolas" panose="020B0609020204030204" pitchFamily="49" charset="0"/>
+                <a:ea typeface="Times New Roman" panose="02020603050405020304" pitchFamily="18" charset="0"/>
+                <a:cs typeface="Times New Roman" panose="02020603050405020304" pitchFamily="18" charset="0"/>
+              </a:rPr>
+              <a:t>=10)</a:t>
+            </a:r>
+            <a:endParaRPr lang="it-IT" sz="1600" dirty="0">
+              <a:solidFill>
+                <a:srgbClr val="00B050"/>
+              </a:solidFill>
+              <a:latin typeface="Century Gothic" panose="020B0502020202020204" pitchFamily="34" charset="0"/>
+              <a:ea typeface="Times New Roman" panose="02020603050405020304" pitchFamily="18" charset="0"/>
+              <a:cs typeface="Tahoma" panose="020B0604030504040204" pitchFamily="34" charset="0"/>
+            </a:endParaRPr>
+          </a:p>
+          <a:p>
+            <a:pPr>
+              <a:lnSpc>
+                <a:spcPct val="115000"/>
+              </a:lnSpc>
+              <a:spcBef>
+                <a:spcPts val="500"/>
+              </a:spcBef>
+              <a:spcAft>
+                <a:spcPts val="0"/>
+              </a:spcAft>
+            </a:pPr>
+            <a:r>
+              <a:rPr lang="en-IN" sz="1400" dirty="0" err="1">
+                <a:solidFill>
+                  <a:srgbClr val="00B050"/>
+                </a:solidFill>
+                <a:latin typeface="Consolas" panose="020B0609020204030204" pitchFamily="49" charset="0"/>
+                <a:ea typeface="Times New Roman" panose="02020603050405020304" pitchFamily="18" charset="0"/>
+                <a:cs typeface="Times New Roman" panose="02020603050405020304" pitchFamily="18" charset="0"/>
+              </a:rPr>
+              <a:t>rfm</a:t>
+            </a:r>
+            <a:r>
+              <a:rPr lang="en-IN" sz="1400" dirty="0">
+                <a:solidFill>
+                  <a:srgbClr val="00B050"/>
+                </a:solidFill>
+                <a:latin typeface="Consolas" panose="020B0609020204030204" pitchFamily="49" charset="0"/>
+                <a:ea typeface="Times New Roman" panose="02020603050405020304" pitchFamily="18" charset="0"/>
+                <a:cs typeface="Times New Roman" panose="02020603050405020304" pitchFamily="18" charset="0"/>
+              </a:rPr>
+              <a:t>['Cluster'] = </a:t>
+            </a:r>
+            <a:r>
+              <a:rPr lang="en-IN" sz="1400" dirty="0" err="1">
+                <a:solidFill>
+                  <a:srgbClr val="00B050"/>
+                </a:solidFill>
+                <a:latin typeface="Consolas" panose="020B0609020204030204" pitchFamily="49" charset="0"/>
+                <a:ea typeface="Times New Roman" panose="02020603050405020304" pitchFamily="18" charset="0"/>
+                <a:cs typeface="Times New Roman" panose="02020603050405020304" pitchFamily="18" charset="0"/>
+              </a:rPr>
+              <a:t>kmeans.</a:t>
+            </a:r>
+            <a:r>
+              <a:rPr lang="en-IN" sz="1400" dirty="0" err="1">
+                <a:highlight>
+                  <a:srgbClr val="00FFFF"/>
+                </a:highlight>
+                <a:latin typeface="Consolas" panose="020B0609020204030204" pitchFamily="49" charset="0"/>
+                <a:ea typeface="Times New Roman" panose="02020603050405020304" pitchFamily="18" charset="0"/>
+                <a:cs typeface="Times New Roman" panose="02020603050405020304" pitchFamily="18" charset="0"/>
+              </a:rPr>
+              <a:t>fit_predict</a:t>
+            </a:r>
+            <a:r>
+              <a:rPr lang="en-IN" sz="1400" dirty="0">
+                <a:highlight>
+                  <a:srgbClr val="00FFFF"/>
+                </a:highlight>
+                <a:latin typeface="Consolas" panose="020B0609020204030204" pitchFamily="49" charset="0"/>
+                <a:ea typeface="Times New Roman" panose="02020603050405020304" pitchFamily="18" charset="0"/>
+                <a:cs typeface="Times New Roman" panose="02020603050405020304" pitchFamily="18" charset="0"/>
+              </a:rPr>
+              <a:t>(</a:t>
+            </a:r>
+            <a:r>
+              <a:rPr lang="en-IN" sz="1400" dirty="0" err="1">
+                <a:highlight>
+                  <a:srgbClr val="00FFFF"/>
+                </a:highlight>
+                <a:latin typeface="Consolas" panose="020B0609020204030204" pitchFamily="49" charset="0"/>
+                <a:ea typeface="Times New Roman" panose="02020603050405020304" pitchFamily="18" charset="0"/>
+                <a:cs typeface="Times New Roman" panose="02020603050405020304" pitchFamily="18" charset="0"/>
+              </a:rPr>
+              <a:t>rfm_scaled</a:t>
+            </a:r>
+            <a:r>
+              <a:rPr lang="en-IN" sz="1400" dirty="0">
+                <a:highlight>
+                  <a:srgbClr val="00FFFF"/>
+                </a:highlight>
+                <a:latin typeface="Consolas" panose="020B0609020204030204" pitchFamily="49" charset="0"/>
+                <a:ea typeface="Times New Roman" panose="02020603050405020304" pitchFamily="18" charset="0"/>
+                <a:cs typeface="Times New Roman" panose="02020603050405020304" pitchFamily="18" charset="0"/>
+              </a:rPr>
+              <a:t>) </a:t>
+            </a:r>
+            <a:endParaRPr lang="it-IT" sz="1600" dirty="0">
+              <a:effectLst/>
+              <a:highlight>
+                <a:srgbClr val="00FFFF"/>
+              </a:highlight>
+              <a:latin typeface="Century Gothic" panose="020B0502020202020204" pitchFamily="34" charset="0"/>
+              <a:ea typeface="Times New Roman" panose="02020603050405020304" pitchFamily="18" charset="0"/>
+              <a:cs typeface="Tahoma" panose="020B0604030504040204" pitchFamily="34" charset="0"/>
+            </a:endParaRPr>
+          </a:p>
+        </p:txBody>
+      </p:sp>
+      <p:sp>
+        <p:nvSpPr>
+          <p:cNvPr id="7" name="CasellaDiTesto 6">
+            <a:extLst>
+              <a:ext uri="{FF2B5EF4-FFF2-40B4-BE49-F238E27FC236}">
+                <a16:creationId xmlns:a16="http://schemas.microsoft.com/office/drawing/2014/main" id="{B1BC4218-9B1E-48E2-92FA-0A01296EE70C}"/>
+              </a:ext>
+            </a:extLst>
+          </p:cNvPr>
+          <p:cNvSpPr txBox="1"/>
+          <p:nvPr/>
+        </p:nvSpPr>
+        <p:spPr>
+          <a:xfrm>
+            <a:off x="6815579" y="1140643"/>
+            <a:ext cx="5250730" cy="1569660"/>
+          </a:xfrm>
+          <a:prstGeom prst="rect">
+            <a:avLst/>
+          </a:prstGeom>
+          <a:noFill/>
+        </p:spPr>
+        <p:txBody>
+          <a:bodyPr wrap="square" rtlCol="0">
+            <a:spAutoFit/>
+          </a:bodyPr>
+          <a:lstStyle/>
+          <a:p>
+            <a:r>
+              <a:rPr lang="it-IT" b="1" dirty="0"/>
+              <a:t>Cluster 2 — Champions</a:t>
+            </a:r>
+            <a:endParaRPr lang="it-IT" dirty="0"/>
+          </a:p>
+          <a:p>
+            <a:pPr marL="285750" lvl="0" indent="-285750">
+              <a:buFont typeface="Arial" panose="020B0604020202020204" pitchFamily="34" charset="0"/>
+              <a:buChar char="•"/>
+            </a:pPr>
+            <a:r>
+              <a:rPr lang="en-IN" sz="1200" dirty="0"/>
+              <a:t>8,103 accounts | $10,680 </a:t>
+            </a:r>
+            <a:r>
+              <a:rPr lang="en-IN" sz="1200" dirty="0" err="1"/>
+              <a:t>avg</a:t>
+            </a:r>
+            <a:r>
+              <a:rPr lang="en-IN" sz="1200" dirty="0"/>
+              <a:t> revenue | Active within 25 days</a:t>
+            </a:r>
+            <a:endParaRPr lang="it-IT" sz="1200" dirty="0"/>
+          </a:p>
+          <a:p>
+            <a:pPr marL="285750" lvl="0" indent="-285750">
+              <a:buFont typeface="Arial" panose="020B0604020202020204" pitchFamily="34" charset="0"/>
+              <a:buChar char="•"/>
+            </a:pPr>
+            <a:r>
+              <a:rPr lang="en-IN" sz="1200" dirty="0"/>
+              <a:t>Highest-value designers, top revenue drivers</a:t>
+            </a:r>
+            <a:endParaRPr lang="it-IT" sz="1200" dirty="0"/>
+          </a:p>
+          <a:p>
+            <a:pPr marL="285750" lvl="0" indent="-285750">
+              <a:buFont typeface="Arial" panose="020B0604020202020204" pitchFamily="34" charset="0"/>
+              <a:buChar char="•"/>
+            </a:pPr>
+            <a:r>
+              <a:rPr lang="en-IN" sz="1200" dirty="0"/>
+              <a:t>22.8 orders on average — frequent, high-spend buyers</a:t>
+            </a:r>
+            <a:endParaRPr lang="it-IT" sz="1200" dirty="0"/>
+          </a:p>
+          <a:p>
+            <a:pPr marL="285750" lvl="0" indent="-285750">
+              <a:buFont typeface="Arial" panose="020B0604020202020204" pitchFamily="34" charset="0"/>
+              <a:buChar char="•"/>
+            </a:pPr>
+            <a:r>
+              <a:rPr lang="en-IN" sz="1200" dirty="0"/>
+              <a:t>White-glove treatment: dedicated reps, early collection access, loyalty perks</a:t>
+            </a:r>
+            <a:endParaRPr lang="it-IT" sz="1200" dirty="0"/>
+          </a:p>
+          <a:p>
+            <a:endParaRPr lang="it-IT" dirty="0"/>
+          </a:p>
+        </p:txBody>
+      </p:sp>
+      <p:sp>
+        <p:nvSpPr>
+          <p:cNvPr id="15" name="CasellaDiTesto 14">
+            <a:extLst>
+              <a:ext uri="{FF2B5EF4-FFF2-40B4-BE49-F238E27FC236}">
+                <a16:creationId xmlns:a16="http://schemas.microsoft.com/office/drawing/2014/main" id="{ED8558D7-1DF8-4775-92AA-15BDA2B80D23}"/>
+              </a:ext>
+            </a:extLst>
+          </p:cNvPr>
+          <p:cNvSpPr txBox="1"/>
+          <p:nvPr/>
+        </p:nvSpPr>
+        <p:spPr>
+          <a:xfrm>
+            <a:off x="6815579" y="2450042"/>
+            <a:ext cx="5137608" cy="1384995"/>
+          </a:xfrm>
+          <a:prstGeom prst="rect">
+            <a:avLst/>
+          </a:prstGeom>
+          <a:noFill/>
+        </p:spPr>
+        <p:txBody>
+          <a:bodyPr wrap="square" rtlCol="0">
+            <a:spAutoFit/>
+          </a:bodyPr>
+          <a:lstStyle/>
+          <a:p>
+            <a:r>
+              <a:rPr lang="it-IT" b="1" dirty="0"/>
+              <a:t>Cluster 0 — At-Risk / </a:t>
+            </a:r>
+            <a:r>
+              <a:rPr lang="it-IT" b="1" dirty="0" err="1"/>
+              <a:t>Lapsed</a:t>
+            </a:r>
+            <a:endParaRPr lang="it-IT" dirty="0"/>
+          </a:p>
+          <a:p>
+            <a:pPr marL="171450" lvl="0" indent="-171450">
+              <a:buFont typeface="Arial" panose="020B0604020202020204" pitchFamily="34" charset="0"/>
+              <a:buChar char="•"/>
+            </a:pPr>
+            <a:r>
+              <a:rPr lang="en-IN" sz="1200" dirty="0"/>
+              <a:t>9,655 accounts | $2,737 </a:t>
+            </a:r>
+            <a:r>
+              <a:rPr lang="en-IN" sz="1200" dirty="0" err="1"/>
+              <a:t>avg</a:t>
+            </a:r>
+            <a:r>
+              <a:rPr lang="en-IN" sz="1200" dirty="0"/>
+              <a:t> revenue | Inactive for ~4 months</a:t>
+            </a:r>
+            <a:endParaRPr lang="it-IT" sz="1200" dirty="0"/>
+          </a:p>
+          <a:p>
+            <a:pPr marL="171450" lvl="0" indent="-171450">
+              <a:buFont typeface="Arial" panose="020B0604020202020204" pitchFamily="34" charset="0"/>
+              <a:buChar char="•"/>
+            </a:pPr>
+            <a:r>
+              <a:rPr lang="en-IN" sz="1200" dirty="0"/>
+              <a:t>Proven buyers drifting away — highest win-back ROI</a:t>
+            </a:r>
+            <a:endParaRPr lang="it-IT" sz="1200" dirty="0"/>
+          </a:p>
+          <a:p>
+            <a:pPr marL="171450" lvl="0" indent="-171450">
+              <a:buFont typeface="Arial" panose="020B0604020202020204" pitchFamily="34" charset="0"/>
+              <a:buChar char="•"/>
+            </a:pPr>
+            <a:r>
+              <a:rPr lang="it-IT" sz="1200" dirty="0" err="1"/>
+              <a:t>Personalized</a:t>
+            </a:r>
+            <a:r>
+              <a:rPr lang="it-IT" sz="1200" dirty="0"/>
+              <a:t> </a:t>
+            </a:r>
+            <a:r>
+              <a:rPr lang="it-IT" sz="1200" dirty="0" err="1"/>
+              <a:t>outreach</a:t>
+            </a:r>
+            <a:r>
+              <a:rPr lang="it-IT" sz="1200" dirty="0"/>
+              <a:t> </a:t>
+            </a:r>
+            <a:r>
+              <a:rPr lang="it-IT" sz="1200" dirty="0" err="1"/>
+              <a:t>referencing</a:t>
+            </a:r>
+            <a:r>
+              <a:rPr lang="it-IT" sz="1200" dirty="0"/>
+              <a:t> </a:t>
+            </a:r>
+            <a:r>
+              <a:rPr lang="it-IT" sz="1200" dirty="0" err="1"/>
+              <a:t>past</a:t>
+            </a:r>
+            <a:r>
+              <a:rPr lang="it-IT" sz="1200" dirty="0"/>
+              <a:t> </a:t>
+            </a:r>
+            <a:r>
+              <a:rPr lang="it-IT" sz="1200" dirty="0" err="1"/>
+              <a:t>purchases</a:t>
+            </a:r>
+            <a:endParaRPr lang="it-IT" sz="1200" dirty="0"/>
+          </a:p>
+          <a:p>
+            <a:pPr marL="171450" lvl="0" indent="-171450">
+              <a:buFont typeface="Arial" panose="020B0604020202020204" pitchFamily="34" charset="0"/>
+              <a:buChar char="•"/>
+            </a:pPr>
+            <a:r>
+              <a:rPr lang="en-IN" sz="1200" dirty="0"/>
+              <a:t>Targeted sampling of new arrivals + time-limited trade incentives</a:t>
+            </a:r>
+            <a:endParaRPr lang="it-IT" sz="1200" dirty="0"/>
+          </a:p>
+          <a:p>
+            <a:endParaRPr lang="it-IT" dirty="0"/>
+          </a:p>
+        </p:txBody>
+      </p:sp>
+      <p:sp>
+        <p:nvSpPr>
+          <p:cNvPr id="16" name="CasellaDiTesto 15">
+            <a:extLst>
+              <a:ext uri="{FF2B5EF4-FFF2-40B4-BE49-F238E27FC236}">
+                <a16:creationId xmlns:a16="http://schemas.microsoft.com/office/drawing/2014/main" id="{F2F1C844-17B5-401F-AF1D-6B57A7333A46}"/>
+              </a:ext>
+            </a:extLst>
+          </p:cNvPr>
+          <p:cNvSpPr txBox="1"/>
+          <p:nvPr/>
+        </p:nvSpPr>
+        <p:spPr>
+          <a:xfrm>
+            <a:off x="6815579" y="3529332"/>
+            <a:ext cx="5376421" cy="1492716"/>
+          </a:xfrm>
+          <a:prstGeom prst="rect">
+            <a:avLst/>
+          </a:prstGeom>
+          <a:noFill/>
+        </p:spPr>
+        <p:txBody>
+          <a:bodyPr wrap="square" rtlCol="0">
+            <a:spAutoFit/>
+          </a:bodyPr>
+          <a:lstStyle/>
+          <a:p>
+            <a:r>
+              <a:rPr lang="it-IT" b="1" dirty="0"/>
+              <a:t>Cluster 3 — New </a:t>
+            </a:r>
+            <a:r>
+              <a:rPr lang="it-IT" b="1" dirty="0" err="1"/>
+              <a:t>Prospects</a:t>
+            </a:r>
+            <a:endParaRPr lang="it-IT" dirty="0"/>
+          </a:p>
+          <a:p>
+            <a:pPr marL="171450" lvl="0" indent="-171450">
+              <a:buFont typeface="Arial" panose="020B0604020202020204" pitchFamily="34" charset="0"/>
+              <a:buChar char="•"/>
+            </a:pPr>
+            <a:r>
+              <a:rPr lang="en-IN" sz="1100" dirty="0"/>
+              <a:t>3,316 accounts | $14 </a:t>
+            </a:r>
+            <a:r>
+              <a:rPr lang="en-IN" sz="1100" dirty="0" err="1"/>
+              <a:t>avg</a:t>
+            </a:r>
+            <a:r>
+              <a:rPr lang="en-IN" sz="1100" dirty="0"/>
+              <a:t> revenue | Active within 36 days</a:t>
+            </a:r>
+            <a:endParaRPr lang="it-IT" sz="1100" dirty="0"/>
+          </a:p>
+          <a:p>
+            <a:pPr marL="171450" lvl="0" indent="-171450">
+              <a:buFont typeface="Arial" panose="020B0604020202020204" pitchFamily="34" charset="0"/>
+              <a:buChar char="•"/>
+            </a:pPr>
+            <a:r>
+              <a:rPr lang="en-IN" sz="1100" dirty="0"/>
+              <a:t>Sampling actively, not yet converting — normal pre-purchase </a:t>
+            </a:r>
+            <a:r>
+              <a:rPr lang="en-IN" sz="1100" dirty="0" err="1"/>
+              <a:t>behavior</a:t>
+            </a:r>
+            <a:endParaRPr lang="it-IT" sz="1100" dirty="0"/>
+          </a:p>
+          <a:p>
+            <a:pPr marL="171450" lvl="0" indent="-171450">
+              <a:buFont typeface="Arial" panose="020B0604020202020204" pitchFamily="34" charset="0"/>
+              <a:buChar char="•"/>
+            </a:pPr>
+            <a:r>
+              <a:rPr lang="en-IN" sz="1100" dirty="0"/>
+              <a:t>Average of 37 samples needed before first sale</a:t>
+            </a:r>
+            <a:endParaRPr lang="it-IT" sz="1100" dirty="0"/>
+          </a:p>
+          <a:p>
+            <a:pPr marL="171450" lvl="0" indent="-171450">
+              <a:buFont typeface="Arial" panose="020B0604020202020204" pitchFamily="34" charset="0"/>
+              <a:buChar char="•"/>
+            </a:pPr>
+            <a:r>
+              <a:rPr lang="en-IN" sz="1100" dirty="0"/>
+              <a:t>Nurture with product education; flag near-threshold accounts for outreach</a:t>
+            </a:r>
+            <a:endParaRPr lang="it-IT" sz="1100" dirty="0"/>
+          </a:p>
+          <a:p>
+            <a:endParaRPr lang="it-IT" dirty="0"/>
+          </a:p>
+        </p:txBody>
+      </p:sp>
+    </p:spTree>
+    <p:extLst>
+      <p:ext uri="{BB962C8B-B14F-4D97-AF65-F5344CB8AC3E}">
+        <p14:creationId xmlns:p14="http://schemas.microsoft.com/office/powerpoint/2010/main" val="1121039344"/>
+      </p:ext>
+    </p:extLst>
+  </p:cSld>
+  <p:clrMapOvr>
+    <a:masterClrMapping/>
+  </p:clrMapOvr>
+</p:sld>
+</file>
+
+<file path=ppt/slides/slide9.xml><?xml version="1.0" encoding="utf-8"?>
+<p:sld xmlns:a="http://schemas.openxmlformats.org/drawingml/2006/main" xmlns:r="http://schemas.openxmlformats.org/officeDocument/2006/relationships" xmlns:p="http://schemas.openxmlformats.org/presentationml/2006/main">
+  <p:cSld>
+    <p:spTree>
+      <p:nvGrpSpPr>
+        <p:cNvPr id="1" name=""/>
+        <p:cNvGrpSpPr/>
+        <p:nvPr/>
+      </p:nvGrpSpPr>
+      <p:grpSpPr>
+        <a:xfrm>
+          <a:off x="0" y="0"/>
+          <a:ext cx="0" cy="0"/>
+          <a:chOff x="0" y="0"/>
+          <a:chExt cx="0" cy="0"/>
+        </a:xfrm>
+      </p:grpSpPr>
+      <p:sp>
+        <p:nvSpPr>
+          <p:cNvPr id="2" name="Titolo 1">
+            <a:extLst>
+              <a:ext uri="{FF2B5EF4-FFF2-40B4-BE49-F238E27FC236}">
                 <a16:creationId xmlns:a16="http://schemas.microsoft.com/office/drawing/2014/main" id="{E5C77E54-A891-48F4-9447-F5F10B30242B}"/>
               </a:ext>
             </a:extLst>
@@ -11598,331 +12600,6 @@
     <p:extLst>
       <p:ext uri="{BB962C8B-B14F-4D97-AF65-F5344CB8AC3E}">
         <p14:creationId xmlns:p14="http://schemas.microsoft.com/office/powerpoint/2010/main" val="3921826632"/>
-      </p:ext>
-    </p:extLst>
-  </p:cSld>
-  <p:clrMapOvr>
-    <a:masterClrMapping/>
-  </p:clrMapOvr>
-</p:sld>
-</file>
-
-<file path=ppt/slides/slide9.xml><?xml version="1.0" encoding="utf-8"?>
-<p:sld xmlns:a="http://schemas.openxmlformats.org/drawingml/2006/main" xmlns:r="http://schemas.openxmlformats.org/officeDocument/2006/relationships" xmlns:p="http://schemas.openxmlformats.org/presentationml/2006/main">
-  <p:cSld>
-    <p:spTree>
-      <p:nvGrpSpPr>
-        <p:cNvPr id="1" name=""/>
-        <p:cNvGrpSpPr/>
-        <p:nvPr/>
-      </p:nvGrpSpPr>
-      <p:grpSpPr>
-        <a:xfrm>
-          <a:off x="0" y="0"/>
-          <a:ext cx="0" cy="0"/>
-          <a:chOff x="0" y="0"/>
-          <a:chExt cx="0" cy="0"/>
-        </a:xfrm>
-      </p:grpSpPr>
-      <p:pic>
-        <p:nvPicPr>
-          <p:cNvPr id="4" name="Immagine 3">
-            <a:extLst>
-              <a:ext uri="{FF2B5EF4-FFF2-40B4-BE49-F238E27FC236}">
-                <a16:creationId xmlns:a16="http://schemas.microsoft.com/office/drawing/2014/main" id="{797287A1-0FF5-40FC-AD2A-1ED2CF0D132C}"/>
-              </a:ext>
-            </a:extLst>
-          </p:cNvPr>
-          <p:cNvPicPr/>
-          <p:nvPr/>
-        </p:nvPicPr>
-        <p:blipFill>
-          <a:blip r:embed="rId2">
-            <a:extLst>
-              <a:ext uri="{28A0092B-C50C-407E-A947-70E740481C1C}">
-                <a14:useLocalDpi xmlns:a14="http://schemas.microsoft.com/office/drawing/2010/main" val="0"/>
-              </a:ext>
-            </a:extLst>
-          </a:blip>
-          <a:stretch>
-            <a:fillRect/>
-          </a:stretch>
-        </p:blipFill>
-        <p:spPr>
-          <a:xfrm>
-            <a:off x="203516" y="0"/>
-            <a:ext cx="5892483" cy="3629320"/>
-          </a:xfrm>
-          <a:prstGeom prst="rect">
-            <a:avLst/>
-          </a:prstGeom>
-        </p:spPr>
-      </p:pic>
-      <p:sp>
-        <p:nvSpPr>
-          <p:cNvPr id="5" name="Rettangolo 4">
-            <a:extLst>
-              <a:ext uri="{FF2B5EF4-FFF2-40B4-BE49-F238E27FC236}">
-                <a16:creationId xmlns:a16="http://schemas.microsoft.com/office/drawing/2014/main" id="{17B9DAAB-F413-4CB1-BC5D-1AB58488F3E2}"/>
-              </a:ext>
-            </a:extLst>
-          </p:cNvPr>
-          <p:cNvSpPr/>
-          <p:nvPr/>
-        </p:nvSpPr>
-        <p:spPr>
-          <a:xfrm>
-            <a:off x="6488576" y="340878"/>
-            <a:ext cx="2929007" cy="369332"/>
-          </a:xfrm>
-          <a:prstGeom prst="rect">
-            <a:avLst/>
-          </a:prstGeom>
-        </p:spPr>
-        <p:txBody>
-          <a:bodyPr wrap="none">
-            <a:spAutoFit/>
-          </a:bodyPr>
-          <a:lstStyle/>
-          <a:p>
-            <a:r>
-              <a:rPr lang="en-IN" b="1" dirty="0">
-                <a:latin typeface="Times New Roman" panose="02020603050405020304" pitchFamily="18" charset="0"/>
-                <a:ea typeface="Times New Roman" panose="02020603050405020304" pitchFamily="18" charset="0"/>
-              </a:rPr>
-              <a:t>Goldilocks Zone ($100–250)</a:t>
-            </a:r>
-            <a:endParaRPr lang="it-IT" dirty="0"/>
-          </a:p>
-        </p:txBody>
-      </p:sp>
-      <p:sp>
-        <p:nvSpPr>
-          <p:cNvPr id="6" name="Rettangolo 5">
-            <a:extLst>
-              <a:ext uri="{FF2B5EF4-FFF2-40B4-BE49-F238E27FC236}">
-                <a16:creationId xmlns:a16="http://schemas.microsoft.com/office/drawing/2014/main" id="{CA1AA25B-92E3-4A4C-ACA5-91AD32654BAA}"/>
-              </a:ext>
-            </a:extLst>
-          </p:cNvPr>
-          <p:cNvSpPr/>
-          <p:nvPr/>
-        </p:nvSpPr>
-        <p:spPr>
-          <a:xfrm>
-            <a:off x="6488576" y="906486"/>
-            <a:ext cx="3070071" cy="369332"/>
-          </a:xfrm>
-          <a:prstGeom prst="rect">
-            <a:avLst/>
-          </a:prstGeom>
-        </p:spPr>
-        <p:txBody>
-          <a:bodyPr wrap="none">
-            <a:spAutoFit/>
-          </a:bodyPr>
-          <a:lstStyle/>
-          <a:p>
-            <a:r>
-              <a:rPr lang="en-IN" b="1" dirty="0">
-                <a:latin typeface="Times New Roman" panose="02020603050405020304" pitchFamily="18" charset="0"/>
-                <a:ea typeface="Times New Roman" panose="02020603050405020304" pitchFamily="18" charset="0"/>
-              </a:rPr>
-              <a:t>Positive Momentum ($0–100)</a:t>
-            </a:r>
-            <a:endParaRPr lang="it-IT" dirty="0"/>
-          </a:p>
-        </p:txBody>
-      </p:sp>
-      <p:sp>
-        <p:nvSpPr>
-          <p:cNvPr id="7" name="Rettangolo 6">
-            <a:extLst>
-              <a:ext uri="{FF2B5EF4-FFF2-40B4-BE49-F238E27FC236}">
-                <a16:creationId xmlns:a16="http://schemas.microsoft.com/office/drawing/2014/main" id="{E1A4F43A-9EA4-46BD-AF28-B1DCC3DCC9B2}"/>
-              </a:ext>
-            </a:extLst>
-          </p:cNvPr>
-          <p:cNvSpPr/>
-          <p:nvPr/>
-        </p:nvSpPr>
-        <p:spPr>
-          <a:xfrm>
-            <a:off x="6488576" y="1472094"/>
-            <a:ext cx="3533018" cy="369332"/>
-          </a:xfrm>
-          <a:prstGeom prst="rect">
-            <a:avLst/>
-          </a:prstGeom>
-        </p:spPr>
-        <p:txBody>
-          <a:bodyPr wrap="none">
-            <a:spAutoFit/>
-          </a:bodyPr>
-          <a:lstStyle/>
-          <a:p>
-            <a:r>
-              <a:rPr lang="en-IN" b="1" dirty="0">
-                <a:latin typeface="Times New Roman" panose="02020603050405020304" pitchFamily="18" charset="0"/>
-                <a:ea typeface="Times New Roman" panose="02020603050405020304" pitchFamily="18" charset="0"/>
-              </a:rPr>
-              <a:t>The Resistance Threshold ($250+)</a:t>
-            </a:r>
-            <a:endParaRPr lang="it-IT" dirty="0"/>
-          </a:p>
-        </p:txBody>
-      </p:sp>
-      <p:sp>
-        <p:nvSpPr>
-          <p:cNvPr id="8" name="Rettangolo 7">
-            <a:extLst>
-              <a:ext uri="{FF2B5EF4-FFF2-40B4-BE49-F238E27FC236}">
-                <a16:creationId xmlns:a16="http://schemas.microsoft.com/office/drawing/2014/main" id="{6721472B-5121-4275-BD4C-B776324F5071}"/>
-              </a:ext>
-            </a:extLst>
-          </p:cNvPr>
-          <p:cNvSpPr/>
-          <p:nvPr/>
-        </p:nvSpPr>
-        <p:spPr>
-          <a:xfrm>
-            <a:off x="6489537" y="2037702"/>
-            <a:ext cx="2928046" cy="369332"/>
-          </a:xfrm>
-          <a:prstGeom prst="rect">
-            <a:avLst/>
-          </a:prstGeom>
-        </p:spPr>
-        <p:txBody>
-          <a:bodyPr wrap="none">
-            <a:spAutoFit/>
-          </a:bodyPr>
-          <a:lstStyle/>
-          <a:p>
-            <a:r>
-              <a:rPr lang="en-IN" b="1" dirty="0">
-                <a:latin typeface="Times New Roman" panose="02020603050405020304" pitchFamily="18" charset="0"/>
-                <a:ea typeface="Times New Roman" panose="02020603050405020304" pitchFamily="18" charset="0"/>
-              </a:rPr>
-              <a:t>High-Ticket Friction ($1k+)</a:t>
-            </a:r>
-            <a:endParaRPr lang="it-IT" dirty="0"/>
-          </a:p>
-        </p:txBody>
-      </p:sp>
-      <p:pic>
-        <p:nvPicPr>
-          <p:cNvPr id="9" name="Immagine 8">
-            <a:extLst>
-              <a:ext uri="{FF2B5EF4-FFF2-40B4-BE49-F238E27FC236}">
-                <a16:creationId xmlns:a16="http://schemas.microsoft.com/office/drawing/2014/main" id="{751423F0-F71C-405E-90E7-D8D9FF22BDA6}"/>
-              </a:ext>
-            </a:extLst>
-          </p:cNvPr>
-          <p:cNvPicPr/>
-          <p:nvPr/>
-        </p:nvPicPr>
-        <p:blipFill>
-          <a:blip r:embed="rId3">
-            <a:extLst>
-              <a:ext uri="{28A0092B-C50C-407E-A947-70E740481C1C}">
-                <a14:useLocalDpi xmlns:a14="http://schemas.microsoft.com/office/drawing/2010/main" val="0"/>
-              </a:ext>
-            </a:extLst>
-          </a:blip>
-          <a:stretch>
-            <a:fillRect/>
-          </a:stretch>
-        </p:blipFill>
-        <p:spPr>
-          <a:xfrm>
-            <a:off x="203516" y="3629320"/>
-            <a:ext cx="5892482" cy="3217545"/>
-          </a:xfrm>
-          <a:prstGeom prst="rect">
-            <a:avLst/>
-          </a:prstGeom>
-        </p:spPr>
-      </p:pic>
-      <p:sp>
-        <p:nvSpPr>
-          <p:cNvPr id="10" name="Rettangolo 9">
-            <a:extLst>
-              <a:ext uri="{FF2B5EF4-FFF2-40B4-BE49-F238E27FC236}">
-                <a16:creationId xmlns:a16="http://schemas.microsoft.com/office/drawing/2014/main" id="{9735EFBE-E4DE-4D51-A976-2C3B9C85AB06}"/>
-              </a:ext>
-            </a:extLst>
-          </p:cNvPr>
-          <p:cNvSpPr/>
-          <p:nvPr/>
-        </p:nvSpPr>
-        <p:spPr>
-          <a:xfrm>
-            <a:off x="6281394" y="4267515"/>
-            <a:ext cx="5492685" cy="1754326"/>
-          </a:xfrm>
-          <a:prstGeom prst="rect">
-            <a:avLst/>
-          </a:prstGeom>
-        </p:spPr>
-        <p:txBody>
-          <a:bodyPr wrap="square">
-            <a:spAutoFit/>
-          </a:bodyPr>
-          <a:lstStyle/>
-          <a:p>
-            <a:r>
-              <a:rPr lang="en-US" dirty="0"/>
-              <a:t>The revenue analysis reveals a clear market preference for classic patterns, with </a:t>
-            </a:r>
-            <a:r>
-              <a:rPr lang="en-US" b="1" dirty="0"/>
-              <a:t>Botanical</a:t>
-            </a:r>
-            <a:r>
-              <a:rPr lang="en-US" dirty="0"/>
-              <a:t>, </a:t>
-            </a:r>
-            <a:r>
-              <a:rPr lang="en-US" b="1" dirty="0"/>
-              <a:t>Solid</a:t>
-            </a:r>
-            <a:r>
-              <a:rPr lang="en-US" dirty="0"/>
-              <a:t>, and </a:t>
-            </a:r>
-            <a:r>
-              <a:rPr lang="en-US" b="1" dirty="0"/>
-              <a:t>Floral</a:t>
-            </a:r>
-            <a:r>
-              <a:rPr lang="en-US" dirty="0"/>
-              <a:t> motifs emerging as the primary revenue drivers, each generating nearly double the individual revenue of mid-tier categories like </a:t>
-            </a:r>
-            <a:r>
-              <a:rPr lang="en-US" b="1" dirty="0"/>
-              <a:t>Geometric</a:t>
-            </a:r>
-            <a:r>
-              <a:rPr lang="en-US" dirty="0"/>
-              <a:t> or </a:t>
-            </a:r>
-            <a:r>
-              <a:rPr lang="en-US" b="1" dirty="0"/>
-              <a:t>Texture</a:t>
-            </a:r>
-            <a:r>
-              <a:rPr lang="en-US" dirty="0"/>
-              <a:t>.</a:t>
-            </a:r>
-            <a:endParaRPr lang="it-IT" dirty="0"/>
-          </a:p>
-        </p:txBody>
-      </p:sp>
-    </p:spTree>
-    <p:extLst>
-      <p:ext uri="{BB962C8B-B14F-4D97-AF65-F5344CB8AC3E}">
-        <p14:creationId xmlns:p14="http://schemas.microsoft.com/office/powerpoint/2010/main" val="3324384585"/>
       </p:ext>
     </p:extLst>
   </p:cSld>

</xml_diff>